<commit_message>
feat: upgrade embedded slide workbench with local history and bilingual UI
</commit_message>
<xml_diff>
--- a/examples/workflow.editable.pptx
+++ b/examples/workflow.editable.pptx
@@ -297,7 +297,9 @@
         <c:tickLblPos val="low"/>
         <c:spPr>
           <a:ln w="12700" cap="flat">
-            <a:noFill/>
+            <a:solidFill>
+              <a:srgbClr val="888888"/>
+            </a:solidFill>
             <a:prstDash val="solid"/>
             <a:round/>
           </a:ln>
@@ -307,9 +309,9 @@
           <a:lstStyle/>
           <a:p>
             <a:pPr>
-              <a:defRPr sz="1500" b="0" i="0" u="none" strike="noStrike">
+              <a:defRPr sz="1200" b="0" i="0" u="none" strike="noStrike">
                 <a:solidFill>
-                  <a:srgbClr val="E9F4F5"/>
+                  <a:srgbClr val="000000"/>
                 </a:solidFill>
                 <a:latin typeface="Arial"/>
               </a:defRPr>
@@ -328,8 +330,19 @@
         <c:scaling>
           <c:orientation val="minMax"/>
         </c:scaling>
-        <c:delete val="1"/>
+        <c:delete val="0"/>
         <c:axPos val="l"/>
+        <c:majorGridlines>
+          <c:spPr>
+            <a:ln w="12700" cap="flat">
+              <a:solidFill>
+                <a:srgbClr val="888888"/>
+              </a:solidFill>
+              <a:prstDash val="solid"/>
+              <a:round/>
+            </a:ln>
+          </c:spPr>
+        </c:majorGridlines>
         <c:numFmt formatCode="General" sourceLinked="0"/>
         <c:majorTickMark val="out"/>
         <c:minorTickMark val="none"/>

</xml_diff>